<commit_message>
Finalize repository structure and automation workflows
</commit_message>
<xml_diff>
--- a/resources/figures.pptx
+++ b/resources/figures.pptx
@@ -104,6 +104,11 @@
       </a:defRPr>
     </a:lvl9pPr>
   </p:defaultTextStyle>
+  <p:extLst>
+    <p:ext uri="{EFAFB233-063F-42B5-8137-9DF3F51BA10A}">
+      <p15:sldGuideLst xmlns:p15="http://schemas.microsoft.com/office/powerpoint/2012/main"/>
+    </p:ext>
+  </p:extLst>
 </p:presentation>
 </file>
 
@@ -3649,7 +3654,9 @@
               <a:ext cx="1800000" cy="1800000"/>
             </a:xfrm>
             <a:prstGeom prst="roundRect">
-              <a:avLst/>
+              <a:avLst>
+                <a:gd name="adj" fmla="val 5038"/>
+              </a:avLst>
             </a:prstGeom>
             <a:solidFill>
               <a:srgbClr val="00387D"/>
@@ -4060,10 +4067,10 @@
       </p:grpSp>
       <p:grpSp>
         <p:nvGrpSpPr>
-          <p:cNvPr id="16" name="グループ化 15">
-            <a:extLst>
-              <a:ext uri="{FF2B5EF4-FFF2-40B4-BE49-F238E27FC236}">
-                <a16:creationId xmlns:a16="http://schemas.microsoft.com/office/drawing/2014/main" id="{0EC31F58-6106-2D42-6975-264E1A1BAB86}"/>
+          <p:cNvPr id="2" name="グループ化 1">
+            <a:extLst>
+              <a:ext uri="{FF2B5EF4-FFF2-40B4-BE49-F238E27FC236}">
+                <a16:creationId xmlns:a16="http://schemas.microsoft.com/office/drawing/2014/main" id="{666CA945-81C8-C5B1-54AF-AB7DC6EDA8A6}"/>
               </a:ext>
             </a:extLst>
           </p:cNvPr>
@@ -4072,18 +4079,21 @@
         </p:nvGrpSpPr>
         <p:grpSpPr>
           <a:xfrm>
-            <a:off x="5864970" y="1142976"/>
+            <a:off x="6072940" y="1142976"/>
             <a:ext cx="1800000" cy="1800000"/>
             <a:chOff x="3299783" y="1142976"/>
             <a:chExt cx="1800000" cy="1800000"/>
           </a:xfrm>
+          <a:solidFill>
+            <a:srgbClr val="00387D"/>
+          </a:solidFill>
         </p:grpSpPr>
         <p:sp>
           <p:nvSpPr>
-            <p:cNvPr id="17" name="角丸四角形 16">
+            <p:cNvPr id="3" name="角丸四角形 2">
               <a:extLst>
                 <a:ext uri="{FF2B5EF4-FFF2-40B4-BE49-F238E27FC236}">
-                  <a16:creationId xmlns:a16="http://schemas.microsoft.com/office/drawing/2014/main" id="{FBB3D4A2-9131-AC76-F1A5-5409810C11B7}"/>
+                  <a16:creationId xmlns:a16="http://schemas.microsoft.com/office/drawing/2014/main" id="{4CC4B70B-15EB-B356-4E45-FFDF8AF0A017}"/>
                 </a:ext>
               </a:extLst>
             </p:cNvPr>
@@ -4098,7 +4108,9 @@
               <a:ext cx="1800000" cy="1800000"/>
             </a:xfrm>
             <a:prstGeom prst="roundRect">
-              <a:avLst/>
+              <a:avLst>
+                <a:gd name="adj" fmla="val 5038"/>
+              </a:avLst>
             </a:prstGeom>
             <a:solidFill>
               <a:schemeClr val="bg1"/>
@@ -4134,10 +4146,10 @@
         </p:sp>
         <p:sp>
           <p:nvSpPr>
-            <p:cNvPr id="18" name="テキスト ボックス 17">
+            <p:cNvPr id="5" name="テキスト ボックス 4">
               <a:extLst>
                 <a:ext uri="{FF2B5EF4-FFF2-40B4-BE49-F238E27FC236}">
-                  <a16:creationId xmlns:a16="http://schemas.microsoft.com/office/drawing/2014/main" id="{A4AC216F-B30E-0866-DB95-2CB74095872C}"/>
+                  <a16:creationId xmlns:a16="http://schemas.microsoft.com/office/drawing/2014/main" id="{7BD19939-6142-D9D2-3E59-AC988D088672}"/>
                 </a:ext>
               </a:extLst>
             </p:cNvPr>
@@ -4183,10 +4195,10 @@
         </p:sp>
         <p:grpSp>
           <p:nvGrpSpPr>
-            <p:cNvPr id="19" name="グループ化 18">
+            <p:cNvPr id="13" name="グループ化 12">
               <a:extLst>
                 <a:ext uri="{FF2B5EF4-FFF2-40B4-BE49-F238E27FC236}">
-                  <a16:creationId xmlns:a16="http://schemas.microsoft.com/office/drawing/2014/main" id="{E1CFA870-1D67-518F-2743-CF6BE7D9211E}"/>
+                  <a16:creationId xmlns:a16="http://schemas.microsoft.com/office/drawing/2014/main" id="{06D18BD2-1A46-5617-6CA7-CC7D6B6B38EB}"/>
                 </a:ext>
               </a:extLst>
             </p:cNvPr>
@@ -4200,13 +4212,14 @@
               <a:chOff x="2199817" y="1443209"/>
               <a:chExt cx="1080000" cy="1080000"/>
             </a:xfrm>
+            <a:grpFill/>
           </p:grpSpPr>
           <p:sp>
             <p:nvSpPr>
-              <p:cNvPr id="21" name="ドーナツ 20">
+              <p:cNvPr id="27" name="ドーナツ 26">
                 <a:extLst>
                   <a:ext uri="{FF2B5EF4-FFF2-40B4-BE49-F238E27FC236}">
-                    <a16:creationId xmlns:a16="http://schemas.microsoft.com/office/drawing/2014/main" id="{CDEE05B0-B050-66A5-D45E-8BEC72F386D4}"/>
+                    <a16:creationId xmlns:a16="http://schemas.microsoft.com/office/drawing/2014/main" id="{844FB3DD-E071-463E-45E9-D0AD8C5EAFE7}"/>
                   </a:ext>
                 </a:extLst>
               </p:cNvPr>
@@ -4225,9 +4238,7 @@
                   <a:gd name="adj" fmla="val 7149"/>
                 </a:avLst>
               </a:prstGeom>
-              <a:solidFill>
-                <a:srgbClr val="00387D"/>
-              </a:solidFill>
+              <a:grpFill/>
               <a:ln>
                 <a:noFill/>
               </a:ln>
@@ -4263,10 +4274,10 @@
           </p:sp>
           <p:sp>
             <p:nvSpPr>
-              <p:cNvPr id="22" name="角丸四角形 21">
+              <p:cNvPr id="28" name="角丸四角形 27">
                 <a:extLst>
                   <a:ext uri="{FF2B5EF4-FFF2-40B4-BE49-F238E27FC236}">
-                    <a16:creationId xmlns:a16="http://schemas.microsoft.com/office/drawing/2014/main" id="{C38E757D-0AC5-107F-685F-932A161174D4}"/>
+                    <a16:creationId xmlns:a16="http://schemas.microsoft.com/office/drawing/2014/main" id="{BB6EB6EE-1787-85A1-93C0-BA3EDE852CAA}"/>
                   </a:ext>
                 </a:extLst>
               </p:cNvPr>
@@ -4281,9 +4292,7 @@
               <a:prstGeom prst="roundRect">
                 <a:avLst/>
               </a:prstGeom>
-              <a:solidFill>
-                <a:srgbClr val="00387D"/>
-              </a:solidFill>
+              <a:grpFill/>
               <a:ln>
                 <a:noFill/>
               </a:ln>
@@ -4315,10 +4324,10 @@
           </p:sp>
           <p:sp>
             <p:nvSpPr>
-              <p:cNvPr id="23" name="角丸四角形 22">
+              <p:cNvPr id="29" name="角丸四角形 28">
                 <a:extLst>
                   <a:ext uri="{FF2B5EF4-FFF2-40B4-BE49-F238E27FC236}">
-                    <a16:creationId xmlns:a16="http://schemas.microsoft.com/office/drawing/2014/main" id="{E797F1DE-B6BE-8960-8329-CD04410AE865}"/>
+                    <a16:creationId xmlns:a16="http://schemas.microsoft.com/office/drawing/2014/main" id="{B7063A7E-8242-BBFA-DD02-70823212FD09}"/>
                   </a:ext>
                 </a:extLst>
               </p:cNvPr>
@@ -4333,9 +4342,7 @@
               <a:prstGeom prst="roundRect">
                 <a:avLst/>
               </a:prstGeom>
-              <a:solidFill>
-                <a:srgbClr val="00387D"/>
-              </a:solidFill>
+              <a:grpFill/>
               <a:ln>
                 <a:noFill/>
               </a:ln>
@@ -4367,10 +4374,10 @@
           </p:sp>
           <p:sp>
             <p:nvSpPr>
-              <p:cNvPr id="24" name="角丸四角形 23">
+              <p:cNvPr id="30" name="角丸四角形 29">
                 <a:extLst>
                   <a:ext uri="{FF2B5EF4-FFF2-40B4-BE49-F238E27FC236}">
-                    <a16:creationId xmlns:a16="http://schemas.microsoft.com/office/drawing/2014/main" id="{1288F596-2F92-4DB7-5398-B06FCC6C268B}"/>
+                    <a16:creationId xmlns:a16="http://schemas.microsoft.com/office/drawing/2014/main" id="{06D3921B-65C1-ED71-A55E-DC5F3508DE44}"/>
                   </a:ext>
                 </a:extLst>
               </p:cNvPr>
@@ -4385,9 +4392,7 @@
               <a:prstGeom prst="roundRect">
                 <a:avLst/>
               </a:prstGeom>
-              <a:solidFill>
-                <a:srgbClr val="00387D"/>
-              </a:solidFill>
+              <a:grpFill/>
               <a:ln>
                 <a:noFill/>
               </a:ln>
@@ -4419,10 +4424,10 @@
           </p:sp>
           <p:sp>
             <p:nvSpPr>
-              <p:cNvPr id="25" name="角丸四角形 24">
+              <p:cNvPr id="31" name="角丸四角形 30">
                 <a:extLst>
                   <a:ext uri="{FF2B5EF4-FFF2-40B4-BE49-F238E27FC236}">
-                    <a16:creationId xmlns:a16="http://schemas.microsoft.com/office/drawing/2014/main" id="{FD3FCAD0-7421-9317-6005-EE1AD4E807FC}"/>
+                    <a16:creationId xmlns:a16="http://schemas.microsoft.com/office/drawing/2014/main" id="{D3024756-69AA-8304-90CB-3FA8DE22B5B1}"/>
                   </a:ext>
                 </a:extLst>
               </p:cNvPr>
@@ -4437,9 +4442,7 @@
               <a:prstGeom prst="roundRect">
                 <a:avLst/>
               </a:prstGeom>
-              <a:solidFill>
-                <a:srgbClr val="00387D"/>
-              </a:solidFill>
+              <a:grpFill/>
               <a:ln>
                 <a:noFill/>
               </a:ln>
@@ -4472,10 +4475,10 @@
         </p:grpSp>
         <p:pic>
           <p:nvPicPr>
-            <p:cNvPr id="20" name="グラフィックス 19">
+            <p:cNvPr id="26" name="グラフィックス 25">
               <a:extLst>
                 <a:ext uri="{FF2B5EF4-FFF2-40B4-BE49-F238E27FC236}">
-                  <a16:creationId xmlns:a16="http://schemas.microsoft.com/office/drawing/2014/main" id="{975B3A30-D566-4232-002A-4015DDD5D26F}"/>
+                  <a16:creationId xmlns:a16="http://schemas.microsoft.com/office/drawing/2014/main" id="{82745E80-282B-8BF8-29AE-6E780217275E}"/>
                 </a:ext>
               </a:extLst>
             </p:cNvPr>

</xml_diff>

<commit_message>
refactor: update data structure in generator and scrape_kitchen_cars scripts
</commit_message>
<xml_diff>
--- a/resources/figures.pptx
+++ b/resources/figures.pptx
@@ -4477,7 +4477,7 @@
         </p:nvSpPr>
         <p:spPr>
           <a:xfrm>
-            <a:off x="1538868" y="4650059"/>
+            <a:off x="3000142" y="4640715"/>
             <a:ext cx="1080000" cy="1080000"/>
           </a:xfrm>
           <a:prstGeom prst="roundRect">
@@ -4533,7 +4533,7 @@
         </p:nvGrpSpPr>
         <p:grpSpPr>
           <a:xfrm>
-            <a:off x="1630675" y="4794059"/>
+            <a:off x="3091949" y="4784715"/>
             <a:ext cx="896386" cy="792000"/>
             <a:chOff x="1672682" y="4783874"/>
             <a:chExt cx="896386" cy="792000"/>
@@ -4946,7 +4946,7 @@
         </p:nvSpPr>
         <p:spPr>
           <a:xfrm>
-            <a:off x="2827505" y="4650059"/>
+            <a:off x="4288779" y="4640715"/>
             <a:ext cx="1080000" cy="1080000"/>
           </a:xfrm>
           <a:prstGeom prst="roundRect">
@@ -5002,7 +5002,7 @@
         </p:nvGrpSpPr>
         <p:grpSpPr>
           <a:xfrm>
-            <a:off x="2919312" y="4794059"/>
+            <a:off x="4380586" y="4784715"/>
             <a:ext cx="896386" cy="792000"/>
             <a:chOff x="1672682" y="4783874"/>
             <a:chExt cx="896386" cy="792000"/>
@@ -5415,7 +5415,7 @@
         </p:nvSpPr>
         <p:spPr>
           <a:xfrm>
-            <a:off x="4116142" y="4650059"/>
+            <a:off x="5577416" y="4640715"/>
             <a:ext cx="1080000" cy="1080000"/>
           </a:xfrm>
           <a:prstGeom prst="roundRect">
@@ -5471,7 +5471,7 @@
         </p:nvGrpSpPr>
         <p:grpSpPr>
           <a:xfrm>
-            <a:off x="4207949" y="4794059"/>
+            <a:off x="5669223" y="4784715"/>
             <a:ext cx="896386" cy="792000"/>
             <a:chOff x="1672682" y="4783874"/>
             <a:chExt cx="896386" cy="792000"/>
@@ -5882,7 +5882,7 @@
         </p:nvSpPr>
         <p:spPr>
           <a:xfrm>
-            <a:off x="1934719" y="4732859"/>
+            <a:off x="3395993" y="4723515"/>
             <a:ext cx="646161" cy="914400"/>
           </a:xfrm>
           <a:prstGeom prst="rect">
@@ -5936,7 +5936,7 @@
         </p:nvSpPr>
         <p:spPr>
           <a:xfrm>
-            <a:off x="3525971" y="4732859"/>
+            <a:off x="4987245" y="4723515"/>
             <a:ext cx="330045" cy="914400"/>
           </a:xfrm>
           <a:prstGeom prst="rect">
@@ -5990,7 +5990,7 @@
         </p:nvGrpSpPr>
         <p:grpSpPr>
           <a:xfrm>
-            <a:off x="5892940" y="4650059"/>
+            <a:off x="7354214" y="4640715"/>
             <a:ext cx="1080000" cy="1080000"/>
             <a:chOff x="5892940" y="4650059"/>
             <a:chExt cx="1080000" cy="1080000"/>
@@ -6339,7 +6339,7 @@
         </p:nvSpPr>
         <p:spPr>
           <a:xfrm>
-            <a:off x="1538868" y="3313136"/>
+            <a:off x="3000142" y="3303792"/>
             <a:ext cx="1080000" cy="1080000"/>
           </a:xfrm>
           <a:prstGeom prst="roundRect">
@@ -6395,7 +6395,7 @@
         </p:nvGrpSpPr>
         <p:grpSpPr>
           <a:xfrm>
-            <a:off x="1630675" y="3457136"/>
+            <a:off x="3091949" y="3447792"/>
             <a:ext cx="896386" cy="792000"/>
             <a:chOff x="1672682" y="4783874"/>
             <a:chExt cx="896386" cy="792000"/>
@@ -6802,7 +6802,7 @@
         </p:nvSpPr>
         <p:spPr>
           <a:xfrm>
-            <a:off x="2827505" y="3313136"/>
+            <a:off x="4288779" y="3303792"/>
             <a:ext cx="1080000" cy="1080000"/>
           </a:xfrm>
           <a:prstGeom prst="roundRect">
@@ -6858,7 +6858,7 @@
         </p:nvGrpSpPr>
         <p:grpSpPr>
           <a:xfrm>
-            <a:off x="2919312" y="3457136"/>
+            <a:off x="4380586" y="3447792"/>
             <a:ext cx="896386" cy="792000"/>
             <a:chOff x="1672682" y="4783874"/>
             <a:chExt cx="896386" cy="792000"/>
@@ -7265,7 +7265,7 @@
         </p:nvSpPr>
         <p:spPr>
           <a:xfrm>
-            <a:off x="4116142" y="3313136"/>
+            <a:off x="5577416" y="3303792"/>
             <a:ext cx="1080000" cy="1080000"/>
           </a:xfrm>
           <a:prstGeom prst="roundRect">
@@ -7321,7 +7321,7 @@
         </p:nvGrpSpPr>
         <p:grpSpPr>
           <a:xfrm>
-            <a:off x="4207949" y="3457136"/>
+            <a:off x="5669223" y="3447792"/>
             <a:ext cx="896386" cy="792000"/>
             <a:chOff x="1672682" y="4783874"/>
             <a:chExt cx="896386" cy="792000"/>
@@ -7732,7 +7732,7 @@
         </p:nvSpPr>
         <p:spPr>
           <a:xfrm>
-            <a:off x="1934719" y="3395936"/>
+            <a:off x="3395993" y="3386592"/>
             <a:ext cx="646161" cy="914400"/>
           </a:xfrm>
           <a:prstGeom prst="rect">
@@ -7786,7 +7786,7 @@
         </p:nvSpPr>
         <p:spPr>
           <a:xfrm>
-            <a:off x="3525971" y="3395936"/>
+            <a:off x="4987245" y="3386592"/>
             <a:ext cx="330045" cy="914400"/>
           </a:xfrm>
           <a:prstGeom prst="rect">
@@ -7840,7 +7840,7 @@
         </p:nvGrpSpPr>
         <p:grpSpPr>
           <a:xfrm>
-            <a:off x="5892940" y="3313136"/>
+            <a:off x="7354214" y="3303792"/>
             <a:ext cx="1080000" cy="1080000"/>
             <a:chOff x="5892940" y="4650059"/>
             <a:chExt cx="1080000" cy="1080000"/>
@@ -10141,6 +10141,1046 @@
           </p:spPr>
         </p:pic>
       </p:grpSp>
+      <p:sp>
+        <p:nvSpPr>
+          <p:cNvPr id="7" name="角丸四角形 6">
+            <a:extLst>
+              <a:ext uri="{FF2B5EF4-FFF2-40B4-BE49-F238E27FC236}">
+                <a16:creationId xmlns:a16="http://schemas.microsoft.com/office/drawing/2014/main" id="{ED00D71F-234F-4537-E69E-4D496AF068DF}"/>
+              </a:ext>
+            </a:extLst>
+          </p:cNvPr>
+          <p:cNvSpPr>
+            <a:spLocks noChangeAspect="1"/>
+          </p:cNvSpPr>
+          <p:nvPr/>
+        </p:nvSpPr>
+        <p:spPr>
+          <a:xfrm>
+            <a:off x="1600130" y="4653843"/>
+            <a:ext cx="1080000" cy="1080000"/>
+          </a:xfrm>
+          <a:prstGeom prst="roundRect">
+            <a:avLst>
+              <a:gd name="adj" fmla="val 7374"/>
+            </a:avLst>
+          </a:prstGeom>
+          <a:solidFill>
+            <a:schemeClr val="bg1"/>
+          </a:solidFill>
+          <a:ln>
+            <a:solidFill>
+              <a:srgbClr val="00387D"/>
+            </a:solidFill>
+          </a:ln>
+        </p:spPr>
+        <p:style>
+          <a:lnRef idx="2">
+            <a:schemeClr val="accent1">
+              <a:shade val="15000"/>
+            </a:schemeClr>
+          </a:lnRef>
+          <a:fillRef idx="1">
+            <a:schemeClr val="accent1"/>
+          </a:fillRef>
+          <a:effectRef idx="0">
+            <a:schemeClr val="accent1"/>
+          </a:effectRef>
+          <a:fontRef idx="minor">
+            <a:schemeClr val="lt1"/>
+          </a:fontRef>
+        </p:style>
+        <p:txBody>
+          <a:bodyPr rtlCol="0" anchor="ctr"/>
+          <a:lstStyle/>
+          <a:p>
+            <a:pPr algn="ctr"/>
+            <a:endParaRPr kumimoji="1" lang="ja-JP" altLang="en-US"/>
+          </a:p>
+        </p:txBody>
+      </p:sp>
+      <p:grpSp>
+        <p:nvGrpSpPr>
+          <p:cNvPr id="93" name="グループ化 92">
+            <a:extLst>
+              <a:ext uri="{FF2B5EF4-FFF2-40B4-BE49-F238E27FC236}">
+                <a16:creationId xmlns:a16="http://schemas.microsoft.com/office/drawing/2014/main" id="{582CC97A-1CCE-C836-BE49-1159C4AA617D}"/>
+              </a:ext>
+            </a:extLst>
+          </p:cNvPr>
+          <p:cNvGrpSpPr/>
+          <p:nvPr/>
+        </p:nvGrpSpPr>
+        <p:grpSpPr>
+          <a:xfrm>
+            <a:off x="1691937" y="4797843"/>
+            <a:ext cx="896386" cy="792000"/>
+            <a:chOff x="1672682" y="4783874"/>
+            <a:chExt cx="896386" cy="792000"/>
+          </a:xfrm>
+        </p:grpSpPr>
+        <p:grpSp>
+          <p:nvGrpSpPr>
+            <p:cNvPr id="99" name="グループ化 98">
+              <a:extLst>
+                <a:ext uri="{FF2B5EF4-FFF2-40B4-BE49-F238E27FC236}">
+                  <a16:creationId xmlns:a16="http://schemas.microsoft.com/office/drawing/2014/main" id="{CD527367-A869-FD26-CF98-5D70D5AE40EE}"/>
+                </a:ext>
+              </a:extLst>
+            </p:cNvPr>
+            <p:cNvGrpSpPr/>
+            <p:nvPr/>
+          </p:nvGrpSpPr>
+          <p:grpSpPr>
+            <a:xfrm>
+              <a:off x="1672682" y="4783874"/>
+              <a:ext cx="252000" cy="792000"/>
+              <a:chOff x="1672682" y="4783874"/>
+              <a:chExt cx="252000" cy="792000"/>
+            </a:xfrm>
+          </p:grpSpPr>
+          <p:sp>
+            <p:nvSpPr>
+              <p:cNvPr id="160" name="円/楕円 159">
+                <a:extLst>
+                  <a:ext uri="{FF2B5EF4-FFF2-40B4-BE49-F238E27FC236}">
+                    <a16:creationId xmlns:a16="http://schemas.microsoft.com/office/drawing/2014/main" id="{77C28A1F-67A6-A8A8-A446-51013D5E99D1}"/>
+                  </a:ext>
+                </a:extLst>
+              </p:cNvPr>
+              <p:cNvSpPr>
+                <a:spLocks noChangeAspect="1"/>
+              </p:cNvSpPr>
+              <p:nvPr/>
+            </p:nvSpPr>
+            <p:spPr>
+              <a:xfrm>
+                <a:off x="1672682" y="4783874"/>
+                <a:ext cx="252000" cy="252000"/>
+              </a:xfrm>
+              <a:prstGeom prst="ellipse">
+                <a:avLst/>
+              </a:prstGeom>
+              <a:solidFill>
+                <a:srgbClr val="00387D"/>
+              </a:solidFill>
+              <a:ln>
+                <a:noFill/>
+              </a:ln>
+            </p:spPr>
+            <p:style>
+              <a:lnRef idx="2">
+                <a:schemeClr val="accent1">
+                  <a:shade val="15000"/>
+                </a:schemeClr>
+              </a:lnRef>
+              <a:fillRef idx="1">
+                <a:schemeClr val="accent1"/>
+              </a:fillRef>
+              <a:effectRef idx="0">
+                <a:schemeClr val="accent1"/>
+              </a:effectRef>
+              <a:fontRef idx="minor">
+                <a:schemeClr val="lt1"/>
+              </a:fontRef>
+            </p:style>
+            <p:txBody>
+              <a:bodyPr rtlCol="0" anchor="ctr"/>
+              <a:lstStyle/>
+              <a:p>
+                <a:pPr algn="ctr"/>
+                <a:endParaRPr kumimoji="1" lang="ja-JP" altLang="en-US"/>
+              </a:p>
+            </p:txBody>
+          </p:sp>
+          <p:sp>
+            <p:nvSpPr>
+              <p:cNvPr id="161" name="片側の 2 つの角を丸めた四角形 160">
+                <a:extLst>
+                  <a:ext uri="{FF2B5EF4-FFF2-40B4-BE49-F238E27FC236}">
+                    <a16:creationId xmlns:a16="http://schemas.microsoft.com/office/drawing/2014/main" id="{C9E50600-E32E-9A8E-1590-885D538F1A47}"/>
+                  </a:ext>
+                </a:extLst>
+              </p:cNvPr>
+              <p:cNvSpPr/>
+              <p:nvPr/>
+            </p:nvSpPr>
+            <p:spPr>
+              <a:xfrm>
+                <a:off x="1672682" y="5035874"/>
+                <a:ext cx="252000" cy="540000"/>
+              </a:xfrm>
+              <a:prstGeom prst="round2SameRect">
+                <a:avLst>
+                  <a:gd name="adj1" fmla="val 48873"/>
+                  <a:gd name="adj2" fmla="val 0"/>
+                </a:avLst>
+              </a:prstGeom>
+              <a:solidFill>
+                <a:srgbClr val="00387D"/>
+              </a:solidFill>
+              <a:ln>
+                <a:noFill/>
+              </a:ln>
+            </p:spPr>
+            <p:style>
+              <a:lnRef idx="2">
+                <a:schemeClr val="accent1">
+                  <a:shade val="15000"/>
+                </a:schemeClr>
+              </a:lnRef>
+              <a:fillRef idx="1">
+                <a:schemeClr val="accent1"/>
+              </a:fillRef>
+              <a:effectRef idx="0">
+                <a:schemeClr val="accent1"/>
+              </a:effectRef>
+              <a:fontRef idx="minor">
+                <a:schemeClr val="lt1"/>
+              </a:fontRef>
+            </p:style>
+            <p:txBody>
+              <a:bodyPr rtlCol="0" anchor="ctr"/>
+              <a:lstStyle/>
+              <a:p>
+                <a:pPr algn="ctr"/>
+                <a:endParaRPr kumimoji="1" lang="ja-JP" altLang="en-US"/>
+              </a:p>
+            </p:txBody>
+          </p:sp>
+        </p:grpSp>
+        <p:grpSp>
+          <p:nvGrpSpPr>
+            <p:cNvPr id="154" name="グループ化 153">
+              <a:extLst>
+                <a:ext uri="{FF2B5EF4-FFF2-40B4-BE49-F238E27FC236}">
+                  <a16:creationId xmlns:a16="http://schemas.microsoft.com/office/drawing/2014/main" id="{7E90C5A3-4CDF-1B4A-11A5-1A2473ACA734}"/>
+                </a:ext>
+              </a:extLst>
+            </p:cNvPr>
+            <p:cNvGrpSpPr/>
+            <p:nvPr/>
+          </p:nvGrpSpPr>
+          <p:grpSpPr>
+            <a:xfrm>
+              <a:off x="1994875" y="4783874"/>
+              <a:ext cx="252000" cy="792000"/>
+              <a:chOff x="1672682" y="4783874"/>
+              <a:chExt cx="252000" cy="792000"/>
+            </a:xfrm>
+          </p:grpSpPr>
+          <p:sp>
+            <p:nvSpPr>
+              <p:cNvPr id="158" name="円/楕円 157">
+                <a:extLst>
+                  <a:ext uri="{FF2B5EF4-FFF2-40B4-BE49-F238E27FC236}">
+                    <a16:creationId xmlns:a16="http://schemas.microsoft.com/office/drawing/2014/main" id="{E0326C74-66DB-6DDC-4750-988557D1F013}"/>
+                  </a:ext>
+                </a:extLst>
+              </p:cNvPr>
+              <p:cNvSpPr>
+                <a:spLocks noChangeAspect="1"/>
+              </p:cNvSpPr>
+              <p:nvPr/>
+            </p:nvSpPr>
+            <p:spPr>
+              <a:xfrm>
+                <a:off x="1672682" y="4783874"/>
+                <a:ext cx="252000" cy="252000"/>
+              </a:xfrm>
+              <a:prstGeom prst="ellipse">
+                <a:avLst/>
+              </a:prstGeom>
+              <a:solidFill>
+                <a:srgbClr val="00387D"/>
+              </a:solidFill>
+              <a:ln>
+                <a:noFill/>
+              </a:ln>
+            </p:spPr>
+            <p:style>
+              <a:lnRef idx="2">
+                <a:schemeClr val="accent1">
+                  <a:shade val="15000"/>
+                </a:schemeClr>
+              </a:lnRef>
+              <a:fillRef idx="1">
+                <a:schemeClr val="accent1"/>
+              </a:fillRef>
+              <a:effectRef idx="0">
+                <a:schemeClr val="accent1"/>
+              </a:effectRef>
+              <a:fontRef idx="minor">
+                <a:schemeClr val="lt1"/>
+              </a:fontRef>
+            </p:style>
+            <p:txBody>
+              <a:bodyPr rtlCol="0" anchor="ctr"/>
+              <a:lstStyle/>
+              <a:p>
+                <a:pPr algn="ctr"/>
+                <a:endParaRPr kumimoji="1" lang="ja-JP" altLang="en-US"/>
+              </a:p>
+            </p:txBody>
+          </p:sp>
+          <p:sp>
+            <p:nvSpPr>
+              <p:cNvPr id="159" name="片側の 2 つの角を丸めた四角形 158">
+                <a:extLst>
+                  <a:ext uri="{FF2B5EF4-FFF2-40B4-BE49-F238E27FC236}">
+                    <a16:creationId xmlns:a16="http://schemas.microsoft.com/office/drawing/2014/main" id="{A1EF308D-DB12-9FD4-720E-3330FE3D723C}"/>
+                  </a:ext>
+                </a:extLst>
+              </p:cNvPr>
+              <p:cNvSpPr/>
+              <p:nvPr/>
+            </p:nvSpPr>
+            <p:spPr>
+              <a:xfrm>
+                <a:off x="1672682" y="5035874"/>
+                <a:ext cx="252000" cy="540000"/>
+              </a:xfrm>
+              <a:prstGeom prst="round2SameRect">
+                <a:avLst>
+                  <a:gd name="adj1" fmla="val 48873"/>
+                  <a:gd name="adj2" fmla="val 0"/>
+                </a:avLst>
+              </a:prstGeom>
+              <a:solidFill>
+                <a:srgbClr val="00387D"/>
+              </a:solidFill>
+              <a:ln>
+                <a:noFill/>
+              </a:ln>
+            </p:spPr>
+            <p:style>
+              <a:lnRef idx="2">
+                <a:schemeClr val="accent1">
+                  <a:shade val="15000"/>
+                </a:schemeClr>
+              </a:lnRef>
+              <a:fillRef idx="1">
+                <a:schemeClr val="accent1"/>
+              </a:fillRef>
+              <a:effectRef idx="0">
+                <a:schemeClr val="accent1"/>
+              </a:effectRef>
+              <a:fontRef idx="minor">
+                <a:schemeClr val="lt1"/>
+              </a:fontRef>
+            </p:style>
+            <p:txBody>
+              <a:bodyPr rtlCol="0" anchor="ctr"/>
+              <a:lstStyle/>
+              <a:p>
+                <a:pPr algn="ctr"/>
+                <a:endParaRPr kumimoji="1" lang="ja-JP" altLang="en-US"/>
+              </a:p>
+            </p:txBody>
+          </p:sp>
+        </p:grpSp>
+        <p:grpSp>
+          <p:nvGrpSpPr>
+            <p:cNvPr id="155" name="グループ化 154">
+              <a:extLst>
+                <a:ext uri="{FF2B5EF4-FFF2-40B4-BE49-F238E27FC236}">
+                  <a16:creationId xmlns:a16="http://schemas.microsoft.com/office/drawing/2014/main" id="{ECDC7505-33EC-91C6-4473-A445AB12595A}"/>
+                </a:ext>
+              </a:extLst>
+            </p:cNvPr>
+            <p:cNvGrpSpPr/>
+            <p:nvPr/>
+          </p:nvGrpSpPr>
+          <p:grpSpPr>
+            <a:xfrm>
+              <a:off x="2317068" y="4783874"/>
+              <a:ext cx="252000" cy="792000"/>
+              <a:chOff x="1672682" y="4783874"/>
+              <a:chExt cx="252000" cy="792000"/>
+            </a:xfrm>
+          </p:grpSpPr>
+          <p:sp>
+            <p:nvSpPr>
+              <p:cNvPr id="156" name="円/楕円 155">
+                <a:extLst>
+                  <a:ext uri="{FF2B5EF4-FFF2-40B4-BE49-F238E27FC236}">
+                    <a16:creationId xmlns:a16="http://schemas.microsoft.com/office/drawing/2014/main" id="{21B6A1DE-4097-B393-AC1C-0E023A5B3C2E}"/>
+                  </a:ext>
+                </a:extLst>
+              </p:cNvPr>
+              <p:cNvSpPr>
+                <a:spLocks noChangeAspect="1"/>
+              </p:cNvSpPr>
+              <p:nvPr/>
+            </p:nvSpPr>
+            <p:spPr>
+              <a:xfrm>
+                <a:off x="1672682" y="4783874"/>
+                <a:ext cx="252000" cy="252000"/>
+              </a:xfrm>
+              <a:prstGeom prst="ellipse">
+                <a:avLst/>
+              </a:prstGeom>
+              <a:solidFill>
+                <a:srgbClr val="00387D"/>
+              </a:solidFill>
+              <a:ln>
+                <a:noFill/>
+              </a:ln>
+            </p:spPr>
+            <p:style>
+              <a:lnRef idx="2">
+                <a:schemeClr val="accent1">
+                  <a:shade val="15000"/>
+                </a:schemeClr>
+              </a:lnRef>
+              <a:fillRef idx="1">
+                <a:schemeClr val="accent1"/>
+              </a:fillRef>
+              <a:effectRef idx="0">
+                <a:schemeClr val="accent1"/>
+              </a:effectRef>
+              <a:fontRef idx="minor">
+                <a:schemeClr val="lt1"/>
+              </a:fontRef>
+            </p:style>
+            <p:txBody>
+              <a:bodyPr rtlCol="0" anchor="ctr"/>
+              <a:lstStyle/>
+              <a:p>
+                <a:pPr algn="ctr"/>
+                <a:endParaRPr kumimoji="1" lang="ja-JP" altLang="en-US"/>
+              </a:p>
+            </p:txBody>
+          </p:sp>
+          <p:sp>
+            <p:nvSpPr>
+              <p:cNvPr id="157" name="片側の 2 つの角を丸めた四角形 156">
+                <a:extLst>
+                  <a:ext uri="{FF2B5EF4-FFF2-40B4-BE49-F238E27FC236}">
+                    <a16:creationId xmlns:a16="http://schemas.microsoft.com/office/drawing/2014/main" id="{4711FE12-CADF-0EF5-0767-8FA093590B1F}"/>
+                  </a:ext>
+                </a:extLst>
+              </p:cNvPr>
+              <p:cNvSpPr/>
+              <p:nvPr/>
+            </p:nvSpPr>
+            <p:spPr>
+              <a:xfrm>
+                <a:off x="1672682" y="5035874"/>
+                <a:ext cx="252000" cy="540000"/>
+              </a:xfrm>
+              <a:prstGeom prst="round2SameRect">
+                <a:avLst>
+                  <a:gd name="adj1" fmla="val 48873"/>
+                  <a:gd name="adj2" fmla="val 0"/>
+                </a:avLst>
+              </a:prstGeom>
+              <a:solidFill>
+                <a:srgbClr val="00387D"/>
+              </a:solidFill>
+              <a:ln>
+                <a:noFill/>
+              </a:ln>
+            </p:spPr>
+            <p:style>
+              <a:lnRef idx="2">
+                <a:schemeClr val="accent1">
+                  <a:shade val="15000"/>
+                </a:schemeClr>
+              </a:lnRef>
+              <a:fillRef idx="1">
+                <a:schemeClr val="accent1"/>
+              </a:fillRef>
+              <a:effectRef idx="0">
+                <a:schemeClr val="accent1"/>
+              </a:effectRef>
+              <a:fontRef idx="minor">
+                <a:schemeClr val="lt1"/>
+              </a:fontRef>
+            </p:style>
+            <p:txBody>
+              <a:bodyPr rtlCol="0" anchor="ctr"/>
+              <a:lstStyle/>
+              <a:p>
+                <a:pPr algn="ctr"/>
+                <a:endParaRPr kumimoji="1" lang="ja-JP" altLang="en-US"/>
+              </a:p>
+            </p:txBody>
+          </p:sp>
+        </p:grpSp>
+      </p:grpSp>
+      <p:sp>
+        <p:nvSpPr>
+          <p:cNvPr id="162" name="正方形/長方形 161">
+            <a:extLst>
+              <a:ext uri="{FF2B5EF4-FFF2-40B4-BE49-F238E27FC236}">
+                <a16:creationId xmlns:a16="http://schemas.microsoft.com/office/drawing/2014/main" id="{EFC77D72-2D57-AC30-71F8-3D00CDC4D523}"/>
+              </a:ext>
+            </a:extLst>
+          </p:cNvPr>
+          <p:cNvSpPr/>
+          <p:nvPr/>
+        </p:nvSpPr>
+        <p:spPr>
+          <a:xfrm>
+            <a:off x="1638917" y="4736643"/>
+            <a:ext cx="1003226" cy="914400"/>
+          </a:xfrm>
+          <a:prstGeom prst="rect">
+            <a:avLst/>
+          </a:prstGeom>
+          <a:solidFill>
+            <a:srgbClr val="FFFFFF">
+              <a:alpha val="69804"/>
+            </a:srgbClr>
+          </a:solidFill>
+          <a:ln>
+            <a:noFill/>
+          </a:ln>
+        </p:spPr>
+        <p:style>
+          <a:lnRef idx="2">
+            <a:schemeClr val="accent1">
+              <a:shade val="15000"/>
+            </a:schemeClr>
+          </a:lnRef>
+          <a:fillRef idx="1">
+            <a:schemeClr val="accent1"/>
+          </a:fillRef>
+          <a:effectRef idx="0">
+            <a:schemeClr val="accent1"/>
+          </a:effectRef>
+          <a:fontRef idx="minor">
+            <a:schemeClr val="lt1"/>
+          </a:fontRef>
+        </p:style>
+        <p:txBody>
+          <a:bodyPr rtlCol="0" anchor="ctr"/>
+          <a:lstStyle/>
+          <a:p>
+            <a:pPr algn="ctr"/>
+            <a:endParaRPr kumimoji="1" lang="ja-JP" altLang="en-US"/>
+          </a:p>
+        </p:txBody>
+      </p:sp>
+      <p:sp>
+        <p:nvSpPr>
+          <p:cNvPr id="163" name="角丸四角形 162">
+            <a:extLst>
+              <a:ext uri="{FF2B5EF4-FFF2-40B4-BE49-F238E27FC236}">
+                <a16:creationId xmlns:a16="http://schemas.microsoft.com/office/drawing/2014/main" id="{56968E88-A1F4-0010-08F8-E9DCCBCE60F7}"/>
+              </a:ext>
+            </a:extLst>
+          </p:cNvPr>
+          <p:cNvSpPr>
+            <a:spLocks noChangeAspect="1"/>
+          </p:cNvSpPr>
+          <p:nvPr/>
+        </p:nvSpPr>
+        <p:spPr>
+          <a:xfrm>
+            <a:off x="1600130" y="3316920"/>
+            <a:ext cx="1080000" cy="1080000"/>
+          </a:xfrm>
+          <a:prstGeom prst="roundRect">
+            <a:avLst>
+              <a:gd name="adj" fmla="val 7374"/>
+            </a:avLst>
+          </a:prstGeom>
+          <a:solidFill>
+            <a:srgbClr val="00387D"/>
+          </a:solidFill>
+          <a:ln>
+            <a:solidFill>
+              <a:srgbClr val="00387D"/>
+            </a:solidFill>
+          </a:ln>
+        </p:spPr>
+        <p:style>
+          <a:lnRef idx="2">
+            <a:schemeClr val="accent1">
+              <a:shade val="15000"/>
+            </a:schemeClr>
+          </a:lnRef>
+          <a:fillRef idx="1">
+            <a:schemeClr val="accent1"/>
+          </a:fillRef>
+          <a:effectRef idx="0">
+            <a:schemeClr val="accent1"/>
+          </a:effectRef>
+          <a:fontRef idx="minor">
+            <a:schemeClr val="lt1"/>
+          </a:fontRef>
+        </p:style>
+        <p:txBody>
+          <a:bodyPr rtlCol="0" anchor="ctr"/>
+          <a:lstStyle/>
+          <a:p>
+            <a:pPr algn="ctr"/>
+            <a:endParaRPr kumimoji="1" lang="ja-JP" altLang="en-US"/>
+          </a:p>
+        </p:txBody>
+      </p:sp>
+      <p:grpSp>
+        <p:nvGrpSpPr>
+          <p:cNvPr id="164" name="グループ化 163">
+            <a:extLst>
+              <a:ext uri="{FF2B5EF4-FFF2-40B4-BE49-F238E27FC236}">
+                <a16:creationId xmlns:a16="http://schemas.microsoft.com/office/drawing/2014/main" id="{2AFCC35F-E853-87DB-B0DF-F0DF7EDDF1E4}"/>
+              </a:ext>
+            </a:extLst>
+          </p:cNvPr>
+          <p:cNvGrpSpPr/>
+          <p:nvPr/>
+        </p:nvGrpSpPr>
+        <p:grpSpPr>
+          <a:xfrm>
+            <a:off x="1691937" y="3460920"/>
+            <a:ext cx="896386" cy="792000"/>
+            <a:chOff x="1672682" y="4783874"/>
+            <a:chExt cx="896386" cy="792000"/>
+          </a:xfrm>
+          <a:solidFill>
+            <a:schemeClr val="bg1"/>
+          </a:solidFill>
+        </p:grpSpPr>
+        <p:grpSp>
+          <p:nvGrpSpPr>
+            <p:cNvPr id="165" name="グループ化 164">
+              <a:extLst>
+                <a:ext uri="{FF2B5EF4-FFF2-40B4-BE49-F238E27FC236}">
+                  <a16:creationId xmlns:a16="http://schemas.microsoft.com/office/drawing/2014/main" id="{CB781C92-6120-10E6-56BD-EBE7AD6FAF9D}"/>
+                </a:ext>
+              </a:extLst>
+            </p:cNvPr>
+            <p:cNvGrpSpPr/>
+            <p:nvPr/>
+          </p:nvGrpSpPr>
+          <p:grpSpPr>
+            <a:xfrm>
+              <a:off x="1672682" y="4783874"/>
+              <a:ext cx="252000" cy="792000"/>
+              <a:chOff x="1672682" y="4783874"/>
+              <a:chExt cx="252000" cy="792000"/>
+            </a:xfrm>
+            <a:grpFill/>
+          </p:grpSpPr>
+          <p:sp>
+            <p:nvSpPr>
+              <p:cNvPr id="172" name="円/楕円 171">
+                <a:extLst>
+                  <a:ext uri="{FF2B5EF4-FFF2-40B4-BE49-F238E27FC236}">
+                    <a16:creationId xmlns:a16="http://schemas.microsoft.com/office/drawing/2014/main" id="{61779F83-50B8-2C8B-9059-BCA1B85F39B4}"/>
+                  </a:ext>
+                </a:extLst>
+              </p:cNvPr>
+              <p:cNvSpPr>
+                <a:spLocks noChangeAspect="1"/>
+              </p:cNvSpPr>
+              <p:nvPr/>
+            </p:nvSpPr>
+            <p:spPr>
+              <a:xfrm>
+                <a:off x="1672682" y="4783874"/>
+                <a:ext cx="252000" cy="252000"/>
+              </a:xfrm>
+              <a:prstGeom prst="ellipse">
+                <a:avLst/>
+              </a:prstGeom>
+              <a:grpFill/>
+              <a:ln>
+                <a:noFill/>
+              </a:ln>
+            </p:spPr>
+            <p:style>
+              <a:lnRef idx="2">
+                <a:schemeClr val="accent1">
+                  <a:shade val="15000"/>
+                </a:schemeClr>
+              </a:lnRef>
+              <a:fillRef idx="1">
+                <a:schemeClr val="accent1"/>
+              </a:fillRef>
+              <a:effectRef idx="0">
+                <a:schemeClr val="accent1"/>
+              </a:effectRef>
+              <a:fontRef idx="minor">
+                <a:schemeClr val="lt1"/>
+              </a:fontRef>
+            </p:style>
+            <p:txBody>
+              <a:bodyPr rtlCol="0" anchor="ctr"/>
+              <a:lstStyle/>
+              <a:p>
+                <a:pPr algn="ctr"/>
+                <a:endParaRPr kumimoji="1" lang="ja-JP" altLang="en-US"/>
+              </a:p>
+            </p:txBody>
+          </p:sp>
+          <p:sp>
+            <p:nvSpPr>
+              <p:cNvPr id="173" name="片側の 2 つの角を丸めた四角形 172">
+                <a:extLst>
+                  <a:ext uri="{FF2B5EF4-FFF2-40B4-BE49-F238E27FC236}">
+                    <a16:creationId xmlns:a16="http://schemas.microsoft.com/office/drawing/2014/main" id="{BE58A455-B1E0-320E-0671-ED1C232C96AE}"/>
+                  </a:ext>
+                </a:extLst>
+              </p:cNvPr>
+              <p:cNvSpPr/>
+              <p:nvPr/>
+            </p:nvSpPr>
+            <p:spPr>
+              <a:xfrm>
+                <a:off x="1672682" y="5035874"/>
+                <a:ext cx="252000" cy="540000"/>
+              </a:xfrm>
+              <a:prstGeom prst="round2SameRect">
+                <a:avLst>
+                  <a:gd name="adj1" fmla="val 48873"/>
+                  <a:gd name="adj2" fmla="val 0"/>
+                </a:avLst>
+              </a:prstGeom>
+              <a:grpFill/>
+              <a:ln>
+                <a:noFill/>
+              </a:ln>
+            </p:spPr>
+            <p:style>
+              <a:lnRef idx="2">
+                <a:schemeClr val="accent1">
+                  <a:shade val="15000"/>
+                </a:schemeClr>
+              </a:lnRef>
+              <a:fillRef idx="1">
+                <a:schemeClr val="accent1"/>
+              </a:fillRef>
+              <a:effectRef idx="0">
+                <a:schemeClr val="accent1"/>
+              </a:effectRef>
+              <a:fontRef idx="minor">
+                <a:schemeClr val="lt1"/>
+              </a:fontRef>
+            </p:style>
+            <p:txBody>
+              <a:bodyPr rtlCol="0" anchor="ctr"/>
+              <a:lstStyle/>
+              <a:p>
+                <a:pPr algn="ctr"/>
+                <a:endParaRPr kumimoji="1" lang="ja-JP" altLang="en-US"/>
+              </a:p>
+            </p:txBody>
+          </p:sp>
+        </p:grpSp>
+        <p:grpSp>
+          <p:nvGrpSpPr>
+            <p:cNvPr id="166" name="グループ化 165">
+              <a:extLst>
+                <a:ext uri="{FF2B5EF4-FFF2-40B4-BE49-F238E27FC236}">
+                  <a16:creationId xmlns:a16="http://schemas.microsoft.com/office/drawing/2014/main" id="{199056D5-9711-E72A-8EC4-DF5ABFEB5B4B}"/>
+                </a:ext>
+              </a:extLst>
+            </p:cNvPr>
+            <p:cNvGrpSpPr/>
+            <p:nvPr/>
+          </p:nvGrpSpPr>
+          <p:grpSpPr>
+            <a:xfrm>
+              <a:off x="1994875" y="4783874"/>
+              <a:ext cx="252000" cy="792000"/>
+              <a:chOff x="1672682" y="4783874"/>
+              <a:chExt cx="252000" cy="792000"/>
+            </a:xfrm>
+            <a:grpFill/>
+          </p:grpSpPr>
+          <p:sp>
+            <p:nvSpPr>
+              <p:cNvPr id="170" name="円/楕円 169">
+                <a:extLst>
+                  <a:ext uri="{FF2B5EF4-FFF2-40B4-BE49-F238E27FC236}">
+                    <a16:creationId xmlns:a16="http://schemas.microsoft.com/office/drawing/2014/main" id="{28A5BBA7-058B-B001-0A97-C0425C42E9C6}"/>
+                  </a:ext>
+                </a:extLst>
+              </p:cNvPr>
+              <p:cNvSpPr>
+                <a:spLocks noChangeAspect="1"/>
+              </p:cNvSpPr>
+              <p:nvPr/>
+            </p:nvSpPr>
+            <p:spPr>
+              <a:xfrm>
+                <a:off x="1672682" y="4783874"/>
+                <a:ext cx="252000" cy="252000"/>
+              </a:xfrm>
+              <a:prstGeom prst="ellipse">
+                <a:avLst/>
+              </a:prstGeom>
+              <a:grpFill/>
+              <a:ln>
+                <a:noFill/>
+              </a:ln>
+            </p:spPr>
+            <p:style>
+              <a:lnRef idx="2">
+                <a:schemeClr val="accent1">
+                  <a:shade val="15000"/>
+                </a:schemeClr>
+              </a:lnRef>
+              <a:fillRef idx="1">
+                <a:schemeClr val="accent1"/>
+              </a:fillRef>
+              <a:effectRef idx="0">
+                <a:schemeClr val="accent1"/>
+              </a:effectRef>
+              <a:fontRef idx="minor">
+                <a:schemeClr val="lt1"/>
+              </a:fontRef>
+            </p:style>
+            <p:txBody>
+              <a:bodyPr rtlCol="0" anchor="ctr"/>
+              <a:lstStyle/>
+              <a:p>
+                <a:pPr algn="ctr"/>
+                <a:endParaRPr kumimoji="1" lang="ja-JP" altLang="en-US"/>
+              </a:p>
+            </p:txBody>
+          </p:sp>
+          <p:sp>
+            <p:nvSpPr>
+              <p:cNvPr id="171" name="片側の 2 つの角を丸めた四角形 170">
+                <a:extLst>
+                  <a:ext uri="{FF2B5EF4-FFF2-40B4-BE49-F238E27FC236}">
+                    <a16:creationId xmlns:a16="http://schemas.microsoft.com/office/drawing/2014/main" id="{5ABE2578-E8DC-AD1A-6161-EF0063E9B186}"/>
+                  </a:ext>
+                </a:extLst>
+              </p:cNvPr>
+              <p:cNvSpPr/>
+              <p:nvPr/>
+            </p:nvSpPr>
+            <p:spPr>
+              <a:xfrm>
+                <a:off x="1672682" y="5035874"/>
+                <a:ext cx="252000" cy="540000"/>
+              </a:xfrm>
+              <a:prstGeom prst="round2SameRect">
+                <a:avLst>
+                  <a:gd name="adj1" fmla="val 48873"/>
+                  <a:gd name="adj2" fmla="val 0"/>
+                </a:avLst>
+              </a:prstGeom>
+              <a:grpFill/>
+              <a:ln>
+                <a:noFill/>
+              </a:ln>
+            </p:spPr>
+            <p:style>
+              <a:lnRef idx="2">
+                <a:schemeClr val="accent1">
+                  <a:shade val="15000"/>
+                </a:schemeClr>
+              </a:lnRef>
+              <a:fillRef idx="1">
+                <a:schemeClr val="accent1"/>
+              </a:fillRef>
+              <a:effectRef idx="0">
+                <a:schemeClr val="accent1"/>
+              </a:effectRef>
+              <a:fontRef idx="minor">
+                <a:schemeClr val="lt1"/>
+              </a:fontRef>
+            </p:style>
+            <p:txBody>
+              <a:bodyPr rtlCol="0" anchor="ctr"/>
+              <a:lstStyle/>
+              <a:p>
+                <a:pPr algn="ctr"/>
+                <a:endParaRPr kumimoji="1" lang="ja-JP" altLang="en-US"/>
+              </a:p>
+            </p:txBody>
+          </p:sp>
+        </p:grpSp>
+        <p:grpSp>
+          <p:nvGrpSpPr>
+            <p:cNvPr id="167" name="グループ化 166">
+              <a:extLst>
+                <a:ext uri="{FF2B5EF4-FFF2-40B4-BE49-F238E27FC236}">
+                  <a16:creationId xmlns:a16="http://schemas.microsoft.com/office/drawing/2014/main" id="{D85523AE-54E0-08DA-DB96-936BC608F587}"/>
+                </a:ext>
+              </a:extLst>
+            </p:cNvPr>
+            <p:cNvGrpSpPr/>
+            <p:nvPr/>
+          </p:nvGrpSpPr>
+          <p:grpSpPr>
+            <a:xfrm>
+              <a:off x="2317068" y="4783874"/>
+              <a:ext cx="252000" cy="792000"/>
+              <a:chOff x="1672682" y="4783874"/>
+              <a:chExt cx="252000" cy="792000"/>
+            </a:xfrm>
+            <a:grpFill/>
+          </p:grpSpPr>
+          <p:sp>
+            <p:nvSpPr>
+              <p:cNvPr id="168" name="円/楕円 167">
+                <a:extLst>
+                  <a:ext uri="{FF2B5EF4-FFF2-40B4-BE49-F238E27FC236}">
+                    <a16:creationId xmlns:a16="http://schemas.microsoft.com/office/drawing/2014/main" id="{C7A55037-7B6E-7DD7-74F0-63C3196EB182}"/>
+                  </a:ext>
+                </a:extLst>
+              </p:cNvPr>
+              <p:cNvSpPr>
+                <a:spLocks noChangeAspect="1"/>
+              </p:cNvSpPr>
+              <p:nvPr/>
+            </p:nvSpPr>
+            <p:spPr>
+              <a:xfrm>
+                <a:off x="1672682" y="4783874"/>
+                <a:ext cx="252000" cy="252000"/>
+              </a:xfrm>
+              <a:prstGeom prst="ellipse">
+                <a:avLst/>
+              </a:prstGeom>
+              <a:grpFill/>
+              <a:ln>
+                <a:noFill/>
+              </a:ln>
+            </p:spPr>
+            <p:style>
+              <a:lnRef idx="2">
+                <a:schemeClr val="accent1">
+                  <a:shade val="15000"/>
+                </a:schemeClr>
+              </a:lnRef>
+              <a:fillRef idx="1">
+                <a:schemeClr val="accent1"/>
+              </a:fillRef>
+              <a:effectRef idx="0">
+                <a:schemeClr val="accent1"/>
+              </a:effectRef>
+              <a:fontRef idx="minor">
+                <a:schemeClr val="lt1"/>
+              </a:fontRef>
+            </p:style>
+            <p:txBody>
+              <a:bodyPr rtlCol="0" anchor="ctr"/>
+              <a:lstStyle/>
+              <a:p>
+                <a:pPr algn="ctr"/>
+                <a:endParaRPr kumimoji="1" lang="ja-JP" altLang="en-US"/>
+              </a:p>
+            </p:txBody>
+          </p:sp>
+          <p:sp>
+            <p:nvSpPr>
+              <p:cNvPr id="169" name="片側の 2 つの角を丸めた四角形 168">
+                <a:extLst>
+                  <a:ext uri="{FF2B5EF4-FFF2-40B4-BE49-F238E27FC236}">
+                    <a16:creationId xmlns:a16="http://schemas.microsoft.com/office/drawing/2014/main" id="{3E370CDA-83E0-DD66-F3AF-56FCA5186A28}"/>
+                  </a:ext>
+                </a:extLst>
+              </p:cNvPr>
+              <p:cNvSpPr/>
+              <p:nvPr/>
+            </p:nvSpPr>
+            <p:spPr>
+              <a:xfrm>
+                <a:off x="1672682" y="5035874"/>
+                <a:ext cx="252000" cy="540000"/>
+              </a:xfrm>
+              <a:prstGeom prst="round2SameRect">
+                <a:avLst>
+                  <a:gd name="adj1" fmla="val 48873"/>
+                  <a:gd name="adj2" fmla="val 0"/>
+                </a:avLst>
+              </a:prstGeom>
+              <a:grpFill/>
+              <a:ln>
+                <a:noFill/>
+              </a:ln>
+            </p:spPr>
+            <p:style>
+              <a:lnRef idx="2">
+                <a:schemeClr val="accent1">
+                  <a:shade val="15000"/>
+                </a:schemeClr>
+              </a:lnRef>
+              <a:fillRef idx="1">
+                <a:schemeClr val="accent1"/>
+              </a:fillRef>
+              <a:effectRef idx="0">
+                <a:schemeClr val="accent1"/>
+              </a:effectRef>
+              <a:fontRef idx="minor">
+                <a:schemeClr val="lt1"/>
+              </a:fontRef>
+            </p:style>
+            <p:txBody>
+              <a:bodyPr rtlCol="0" anchor="ctr"/>
+              <a:lstStyle/>
+              <a:p>
+                <a:pPr algn="ctr"/>
+                <a:endParaRPr kumimoji="1" lang="ja-JP" altLang="en-US"/>
+              </a:p>
+            </p:txBody>
+          </p:sp>
+        </p:grpSp>
+      </p:grpSp>
+      <p:sp>
+        <p:nvSpPr>
+          <p:cNvPr id="174" name="正方形/長方形 173">
+            <a:extLst>
+              <a:ext uri="{FF2B5EF4-FFF2-40B4-BE49-F238E27FC236}">
+                <a16:creationId xmlns:a16="http://schemas.microsoft.com/office/drawing/2014/main" id="{5D718F77-A8F4-D269-312E-F15825D625A5}"/>
+              </a:ext>
+            </a:extLst>
+          </p:cNvPr>
+          <p:cNvSpPr/>
+          <p:nvPr/>
+        </p:nvSpPr>
+        <p:spPr>
+          <a:xfrm>
+            <a:off x="1648149" y="3399720"/>
+            <a:ext cx="993993" cy="914400"/>
+          </a:xfrm>
+          <a:prstGeom prst="rect">
+            <a:avLst/>
+          </a:prstGeom>
+          <a:solidFill>
+            <a:srgbClr val="00387D">
+              <a:alpha val="69804"/>
+            </a:srgbClr>
+          </a:solidFill>
+          <a:ln>
+            <a:noFill/>
+          </a:ln>
+        </p:spPr>
+        <p:style>
+          <a:lnRef idx="2">
+            <a:schemeClr val="accent1">
+              <a:shade val="15000"/>
+            </a:schemeClr>
+          </a:lnRef>
+          <a:fillRef idx="1">
+            <a:schemeClr val="accent1"/>
+          </a:fillRef>
+          <a:effectRef idx="0">
+            <a:schemeClr val="accent1"/>
+          </a:effectRef>
+          <a:fontRef idx="minor">
+            <a:schemeClr val="lt1"/>
+          </a:fontRef>
+        </p:style>
+        <p:txBody>
+          <a:bodyPr rtlCol="0" anchor="ctr"/>
+          <a:lstStyle/>
+          <a:p>
+            <a:pPr algn="ctr"/>
+            <a:endParaRPr kumimoji="1" lang="ja-JP" altLang="en-US"/>
+          </a:p>
+        </p:txBody>
+      </p:sp>
     </p:spTree>
     <p:extLst>
       <p:ext uri="{BB962C8B-B14F-4D97-AF65-F5344CB8AC3E}">

</xml_diff>